<commit_message>
docs(s12): describe the ThePower Shop research case and update the S12 deck and script
</commit_message>
<xml_diff>
--- a/material/S12/S12-deep-research-multimodal.pptx
+++ b/material/S12/S12-deep-research-multimodal.pptx
@@ -485,7 +485,7 @@
           </a:p>
           <a:p xmlns:a="http://schemas.openxmlformats.org/drawingml/2006/main">
             <a:r>
-              <a:t>Abre con una situación reconocible: alguien envía una captura y un audio a soporte. La captura muestra un error y el audio explica qué hizo antes. Leer la imagen, entender la petición e investigar la solución son trabajos diferentes. Hoy los conectaremos en un único agente. Venimos de recuperar documentos en S10 y corregir la recuperación en S11. Ahora añadimos entradas que no son solo texto y fuentes que todavía no están en nuestro corpus. El objetivo es que el alumno pueda explicar el recorrido y construir una versión pequeña, con límites y resultados comprobables.</a:t>
+              <a:t>Abre con una situación reconocible: un cliente de ThePower Shop envía a atención al cliente la foto de su pedido y una nota de voz. La foto identifica el pedido y el audio cuenta qué pasó: abrió unos auriculares y el derecho no suena. Leer la imagen, entender la petición e investigar qué dicen la política de la tienda y la normativa son trabajos diferentes. Hoy los conectaremos en un único agente. Venimos de recuperar documentos en S10 y corregir la recuperación en S11 con la misma tienda. Ahora añadimos entradas que no son solo texto, una herramienta que lee pedidos y fuentes que no están en nuestro corpus. El objetivo es que el alumno pueda explicar el recorrido y construir una versión pequeña, con límites y resultados comprobables.</a:t>
             </a:r>
           </a:p>
           <a:p xmlns:a="http://schemas.openxmlformats.org/drawingml/2006/main">
@@ -515,7 +515,7 @@
           </a:p>
           <a:p xmlns:a="http://schemas.openxmlformats.org/drawingml/2006/main">
             <a:r>
-              <a:t>¿Qué información suele faltar cuando alguien solo nos manda una captura?</a:t>
+              <a:t>¿Qué información suele faltar cuando un cliente solo nos manda la foto de un pedido?</a:t>
             </a:r>
           </a:p>
           <a:p xmlns:a="http://schemas.openxmlformats.org/drawingml/2006/main">
@@ -530,7 +530,7 @@
           </a:p>
           <a:p xmlns:a="http://schemas.openxmlformats.org/drawingml/2006/main">
             <a:r>
-              <a:t>La intención y lo que ocurrió antes del error. El audio puede aportar ese contexto.</a:t>
+              <a:t>Qué le pasa al producto y qué quiere el cliente. El audio puede aportar ese contexto.</a:t>
             </a:r>
           </a:p>
           <a:p xmlns:a="http://schemas.openxmlformats.org/drawingml/2006/main">
@@ -660,7 +660,7 @@
           </a:p>
           <a:p xmlns:a="http://schemas.openxmlformats.org/drawingml/2006/main">
             <a:r>
-              <a:t>Recuerda que proponer una herramienta y ejecutarla son pasos distintos. El modelo puede sugerir una llamada, pero el programa comprueba el nombre permitido, los argumentos y los permisos. Nuestra herramienta de solo lectura consulta una ficha del curso. No necesita buscar en la web para recuperar un dato ya estructurado. La pregunta sobre dimensiones sí puede necesitar documentación externa. Una misma investigación puede usar ambas vías. El grupo de la conversación limita qué calendario puede consultar la herramienta. Un texto dentro de una captura nunca cambia esos permisos.</a:t>
+              <a:t>Recuerda que proponer una herramienta y ejecutarla son pasos distintos. El modelo puede sugerir una llamada, pero el programa comprueba el nombre permitido, los argumentos y los permisos. Nuestra herramienta de solo lectura consulta los datos de un pedido: producto, pago, fechas y estado. Esos datos no están en las políticas y no tiene sentido buscarlos en la web. La pregunta sobre la normativa sí necesita fuentes externas. Una misma investigación puede usar ambas vías. La cuenta de la conversación limita qué pedidos puede leer la herramienta. Un número escrito en una foto o en una página nunca cambia ese permiso.</a:t>
             </a:r>
           </a:p>
           <a:p xmlns:a="http://schemas.openxmlformats.org/drawingml/2006/main">
@@ -675,7 +675,7 @@
           </a:p>
           <a:p xmlns:a="http://schemas.openxmlformats.org/drawingml/2006/main">
             <a:r>
-              <a:t>Enseña el contrato conceptual get_course_session({sessionId: 'S12', audience: 'M/J'}). La implementación valida también la audiencia autorizada.</a:t>
+              <a:t>Enseña el contrato conceptual get_order({orderId: 'TPS-20481'}). La implementación comprueba que el pedido pertenece a la cuenta de la conversación.</a:t>
             </a:r>
           </a:p>
           <a:p xmlns:a="http://schemas.openxmlformats.org/drawingml/2006/main">
@@ -690,7 +690,7 @@
           </a:p>
           <a:p xmlns:a="http://schemas.openxmlformats.org/drawingml/2006/main">
             <a:r>
-              <a:t>¿Puede una página externa ordenar que la herramienta consulte el calendario de otro grupo?</a:t>
+              <a:t>¿Puede una página externa o una foto ordenar que la herramienta lea el pedido de otro cliente?</a:t>
             </a:r>
           </a:p>
           <a:p xmlns:a="http://schemas.openxmlformats.org/drawingml/2006/main">
@@ -705,7 +705,7 @@
           </a:p>
           <a:p xmlns:a="http://schemas.openxmlformats.org/drawingml/2006/main">
             <a:r>
-              <a:t>La página es un dato. La autorización la impone el programa.</a:t>
+              <a:t>La página y la foto son datos. La autorización la impone el programa.</a:t>
             </a:r>
           </a:p>
           <a:p xmlns:a="http://schemas.openxmlformats.org/drawingml/2006/main">
@@ -840,7 +840,7 @@
           </a:p>
           <a:p xmlns:a="http://schemas.openxmlformats.org/drawingml/2006/main">
             <a:r>
-              <a:t>Distingue historial de conversación, checkpoint del grafo e informe guardado. El historial ayuda a interpretar ese índice en un turno posterior. El checkpoint conserva el estado de una ejecución. El informe es un resultado que debemos poder recuperar aunque el historial se recorte. thread_id identifica un hilo, pero por sí solo no autoriza el acceso. En nuestra app hay una conversación del propietario y cada trabajo tiene su propio checkpoint. El alumno puede implementar una versión más pequeña, pero debe demostrar dos conversaciones aisladas. Recordar una frase del usuario no la convierte en prueba de cómo funciona un proveedor.</a:t>
+              <a:t>Distingue historial de conversación, checkpoint del grafo e informe guardado. El historial ayuda a interpretar ese pedido en un turno posterior. El checkpoint conserva el estado de una ejecución. El informe es un resultado que debemos poder recuperar aunque el historial se recorte. thread_id identifica un hilo, pero por sí solo no autoriza el acceso. En nuestra app hay una conversación del propietario y cada trabajo tiene su propio checkpoint. El alumno puede implementar una versión más pequeña, pero debe demostrar dos conversaciones aisladas. Recordar una frase del usuario no la convierte en prueba de cómo funciona un proveedor.</a:t>
             </a:r>
           </a:p>
           <a:p xmlns:a="http://schemas.openxmlformats.org/drawingml/2006/main">
@@ -870,7 +870,7 @@
           </a:p>
           <a:p xmlns:a="http://schemas.openxmlformats.org/drawingml/2006/main">
             <a:r>
-              <a:t>Si el usuario dijo que su índice tiene 1024 dimensiones, ¿ya hemos verificado su configuración?</a:t>
+              <a:t>Si el cliente dijo que pagó con tarjeta, ¿ya hemos verificado su método de pago?</a:t>
             </a:r>
           </a:p>
           <a:p xmlns:a="http://schemas.openxmlformats.org/drawingml/2006/main">
@@ -885,7 +885,7 @@
           </a:p>
           <a:p xmlns:a="http://schemas.openxmlformats.org/drawingml/2006/main">
             <a:r>
-              <a:t>Es contexto aportado por el usuario. La configuración necesita una comprobación independiente.</a:t>
+              <a:t>Es contexto aportado por el cliente. El pago necesita una comprobación independiente con la herramienta.</a:t>
             </a:r>
           </a:p>
           <a:p xmlns:a="http://schemas.openxmlformats.org/drawingml/2006/main">
@@ -1020,7 +1020,7 @@
           </a:p>
           <a:p xmlns:a="http://schemas.openxmlformats.org/drawingml/2006/main">
             <a:r>
-              <a:t>Define Deep Research por su recorrido: planificar, reunir evidencia, valorar cobertura y terminar con un informe. El nombre también lo usan productos concretos. Aquí nos interesa comprender el comportamiento antes de escoger proveedor. El plan del caso puede separar la regla general de dimensiones, la configuración que debe comprobarse y su relación con lo visto en el curso. Una búsqueda puede traer una página relevante y aun así dejar una subpregunta sin cubrir. La decisión de seguir depende de esa laguna y de los límites disponibles. Nuestro grafo permite una ronda inicial y una de seguimiento, no un bucle indefinido.</a:t>
+              <a:t>Define Deep Research por su recorrido: planificar, reunir evidencia, valorar cobertura y terminar con un informe. El nombre también lo usan productos concretos. Aquí nos interesa comprender el comportamiento antes de escoger proveedor. El plan del caso puede separar lo que dice la política de la tienda, los datos del pedido y lo que exige la normativa europea. Una búsqueda puede traer una página relevante y aun así dejar una subpregunta sin cubrir. La decisión de seguir depende de esa laguna y de los límites disponibles. Nuestro grafo permite una ronda inicial y una de seguimiento, no un bucle indefinido.</a:t>
             </a:r>
           </a:p>
           <a:p xmlns:a="http://schemas.openxmlformats.org/drawingml/2006/main">
@@ -1035,7 +1035,7 @@
           </a:p>
           <a:p xmlns:a="http://schemas.openxmlformats.org/drawingml/2006/main">
             <a:r>
-              <a:t>Pide dos subpreguntas concretas para el caso. Rechaza planes vagos como investigar todo sobre embeddings.</a:t>
+              <a:t>Pide dos subpreguntas concretas para el caso. Rechaza planes vagos como investigar todo sobre devoluciones.</a:t>
             </a:r>
           </a:p>
           <a:p xmlns:a="http://schemas.openxmlformats.org/drawingml/2006/main">
@@ -1205,7 +1205,7 @@
           </a:p>
           <a:p xmlns:a="http://schemas.openxmlformats.org/drawingml/2006/main">
             <a:r>
-              <a:t>Separa buscar de leer. Un buscador devuelve candidatos y fragmentos resumidos, pero necesitamos leer el contenido relevante. Para una API, priorizamos documentación oficial y comprobamos versión y fecha. Un extracto debe estar relacionado con la subpregunta y conservar su procedencia. La captura de nuestro caso puede demostrar qué texto recibió el agente, pero no cómo está configurado un servicio remoto. Tampoco aceptamos instrucciones encontradas en una página como si fueran órdenes del usuario. La herramienta del curso y la web tienen ámbitos de autoridad diferentes.</a:t>
+              <a:t>Separa buscar de leer. Un buscador devuelve candidatos y fragmentos resumidos, pero necesitamos leer el contenido relevante. Para una norma, priorizamos fuentes oficiales y comprobamos su vigencia y su fecha. Un extracto debe estar relacionado con la subpregunta y conservar su procedencia. La foto de nuestro caso puede demostrar qué texto recibió el agente, pero no el estado real del pedido. Tampoco aceptamos instrucciones encontradas en una página como si fueran órdenes del usuario. Las políticas de la tienda, la herramienta de pedidos y la web tienen ámbitos de autoridad diferentes.</a:t>
             </a:r>
           </a:p>
           <a:p xmlns:a="http://schemas.openxmlformats.org/drawingml/2006/main">
@@ -1220,7 +1220,7 @@
           </a:p>
           <a:p xmlns:a="http://schemas.openxmlformats.org/drawingml/2006/main">
             <a:r>
-              <a:t>Da el ejemplo de una página que documenta una regla general y pregunta qué parte de la configuración del alumno sigue sin probar.</a:t>
+              <a:t>Da el ejemplo de una página que documenta una regla general y pregunta qué parte del caso del cliente sigue sin probar.</a:t>
             </a:r>
           </a:p>
           <a:p xmlns:a="http://schemas.openxmlformats.org/drawingml/2006/main">
@@ -1385,7 +1385,7 @@
           </a:p>
           <a:p xmlns:a="http://schemas.openxmlformats.org/drawingml/2006/main">
             <a:r>
-              <a:t>El programa puede haber completado todas sus llamadas y producir un informe parcial porque ninguna fuente permite confirmar la configuración concreta. Eso es una salida útil si explica la laguna. Nuestro verificador utiliza extractos admitidos y comprueba tramos de texto, cifras y negaciones. Es una elección conservadora que reduce ciertas invenciones, pero limita la síntesis libre y no certifica la verdad universal. Una fuente puede estar desactualizada o ser inadecuada. Mantén separadas la salud de la ejecución, la cobertura de la respuesta y la evaluación humana de su utilidad.</a:t>
+              <a:t>El programa puede haber completado todas sus llamadas y producir un informe parcial porque ninguna fuente cubre una parte de la pregunta, por ejemplo la garantía de un producto defectuoso. Eso es una salida útil si explica la laguna. Nuestro verificador utiliza extractos admitidos y comprueba tramos de texto, cifras y negaciones. Es una elección conservadora que reduce ciertas invenciones, pero limita la síntesis libre y no certifica la verdad universal. Una fuente puede estar desactualizada o ser inadecuada. Mantén separadas la salud de la ejecución, la cobertura de la respuesta y la evaluación humana de su utilidad.</a:t>
             </a:r>
           </a:p>
           <a:p xmlns:a="http://schemas.openxmlformats.org/drawingml/2006/main">
@@ -1400,7 +1400,7 @@
           </a:p>
           <a:p xmlns:a="http://schemas.openxmlformats.org/drawingml/2006/main">
             <a:r>
-              <a:t>Plantea dos salidas: una recomendación tajante de borrar el índice y un informe parcial que pide verificar dimensiones. Compara la evidencia necesaria para cada una.</a:t>
+              <a:t>Plantea dos salidas: una respuesta tajante de que nada abierto se puede devolver y un informe parcial que separa desistimiento y garantía. Compara la evidencia necesaria para cada una.</a:t>
             </a:r>
           </a:p>
           <a:p xmlns:a="http://schemas.openxmlformats.org/drawingml/2006/main">
@@ -1415,7 +1415,7 @@
           </a:p>
           <a:p xmlns:a="http://schemas.openxmlformats.org/drawingml/2006/main">
             <a:r>
-              <a:t>¿Es un fallo que el sistema diga que todavía no puede recomendar el cambio?</a:t>
+              <a:t>¿Es un fallo que el sistema diga que todavía no puede confirmar el reembolso?</a:t>
             </a:r>
           </a:p>
           <a:p xmlns:a="http://schemas.openxmlformats.org/drawingml/2006/main">
@@ -2475,7 +2475,7 @@
           </a:p>
           <a:p xmlns:a="http://schemas.openxmlformats.org/drawingml/2006/main">
             <a:r>
-              <a:t>Deja dos minutos para la encuesta. El QR corresponde a AI Engineer y evalúa S11 del martes 27, la clase anterior. Mientras responden, pide que piensen en una consulta que el corpus no pueda resolver. Puede tratarse de un cambio reciente en una API o de un fallo cuyo contexto solo aparece en una captura. Recoge un ejemplo y úsalo para introducir la investigación externa. No alargues el feedback hasta consumir el bloque conceptual.</a:t>
+              <a:t>Deja dos minutos para la encuesta. El QR corresponde a AI Engineer y evalúa S11 del martes 27, la clase anterior. Mientras responden, pide que piensen en una consulta que el corpus no pueda resolver. Puede tratarse de lo que dice la normativa de consumo o de un problema cuyo contexto solo aparece en una foto. Recoge un ejemplo y úsalo para introducir la investigación externa. No alargues el feedback hasta consumir el bloque conceptual.</a:t>
             </a:r>
           </a:p>
           <a:p xmlns:a="http://schemas.openxmlformats.org/drawingml/2006/main">
@@ -2830,7 +2830,7 @@
           </a:p>
           <a:p xmlns:a="http://schemas.openxmlformats.org/drawingml/2006/main">
             <a:r>
-              <a:t>Presenta las decisiones de la app después de haber explicado las responsabilidades. LangGraph controla la investigación y consulta el curso, una herramienta y la web. El ensayo real se hizo con Claude para texto e imagen, Whisper para audio y Aura para voz. La fábrica actual permite configurar el proveedor generativo, pero no prometemos compatibilidad universal con cualquier modelo de visión. La persistencia utiliza servicios de Cloudflare. Estos nombres describen nuestra implementación y no requisitos conceptuales de multimodalidad. La ruta Gemini/Interactions del enunciado no queda implementada por el hecho de que esta app tenga un grafo equivalente.</a:t>
+              <a:t>Presenta las decisiones de la app después de haber explicado las responsabilidades. LangGraph controla la investigación y consulta las políticas de la tienda, la herramienta de pedidos y la web. El ensayo real se hizo con Claude para texto e imagen, Whisper para audio y Aura para voz. La fábrica actual permite configurar el proveedor generativo, pero no prometemos compatibilidad universal con cualquier modelo de visión. La persistencia utiliza servicios de Cloudflare. Estos nombres describen nuestra implementación y no requisitos conceptuales de multimodalidad. La ruta Gemini/Interactions del enunciado no queda implementada por el hecho de que esta app tenga un grafo equivalente.</a:t>
             </a:r>
           </a:p>
           <a:p xmlns:a="http://schemas.openxmlformats.org/drawingml/2006/main">
@@ -2845,7 +2845,7 @@
           </a:p>
           <a:p xmlns:a="http://schemas.openxmlformats.org/drawingml/2006/main">
             <a:r>
-              <a:t>Abre la app local en 127.0.0.1:5191, grupo M/J y etapa Investigación. Mantén los secretos y las configuraciones operativas fuera de la pantalla compartida.</a:t>
+              <a:t>Abre la app local en 127.0.0.1:5191 y la etapa Investigación. Mantén los secretos y las configuraciones operativas fuera de la pantalla compartida.</a:t>
             </a:r>
           </a:p>
           <a:p xmlns:a="http://schemas.openxmlformats.org/drawingml/2006/main">
@@ -2890,7 +2890,7 @@
           </a:p>
           <a:p xmlns:a="http://schemas.openxmlformats.org/drawingml/2006/main">
             <a:r>
-              <a:t>Vamos a observar cada parte con la captura y el audio del caso.</a:t>
+              <a:t>Vamos a observar cada parte con la foto y la nota de voz del caso.</a:t>
             </a:r>
           </a:p>
           <a:p xmlns:a="http://schemas.openxmlformats.org/drawingml/2006/main">
@@ -3010,7 +3010,7 @@
           </a:p>
           <a:p xmlns:a="http://schemas.openxmlformats.org/drawingml/2006/main">
             <a:r>
-              <a:t>Usa el perfil local de investigación con sus guiones rotulados. Adjunta dimension-mismatch.png y embedding-request.wav, marca Generar voz y envía sin escribir la pregunta. Muestra que la observación y la intención se conservan por separado, que aparecen plan y fuentes y que el resultado se guarda. El tono offline es una prueba técnica, no una voz neural. Recarga y comprueba el mismo informe. Haz un seguimiento breve con ese índice y después abre otra conversación para mostrar aislamiento. El guion detallado y los tiempos de corte están en el apartado de demostración del documento del profesor. La consulta a get_course_session y las fuentes del caso real se pueden recorrer en el respaldo guardado.</a:t>
+              <a:t>Usa el perfil local de investigación con sus guiones rotulados. Adjunta pedido-auriculares.png y nota-de-voz-devolucion.wav, marca Generar voz y envía sin escribir la pregunta. Muestra que la observación y la intención se conservan por separado, que aparecen plan y fuentes y que el resultado se guarda. El tono offline es una prueba técnica, no una voz neural. Recarga y comprueba el mismo informe. Haz un seguimiento breve con «¿y ese pedido?» y después abre otra conversación para mostrar aislamiento. El guion detallado y los tiempos de corte están en el apartado de demostración del documento del profesor. La consulta a get_order y las fuentes del caso real se pueden recorrer en el respaldo guardado.</a:t>
             </a:r>
           </a:p>
           <a:p xmlns:a="http://schemas.openxmlformats.org/drawingml/2006/main">
@@ -3055,7 +3055,7 @@
           </a:p>
           <a:p xmlns:a="http://schemas.openxmlformats.org/drawingml/2006/main">
             <a:r>
-              <a:t>Las cifras del error proceden de la imagen. La regla técnica debe apoyarse en una fuente admitida.</a:t>
+              <a:t>El pedido, el producto y el pago proceden de la imagen. Lo que dicen la tienda y la normativa debe apoyarse en una fuente admitida.</a:t>
             </a:r>
           </a:p>
           <a:p xmlns:a="http://schemas.openxmlformats.org/drawingml/2006/main">
@@ -3725,7 +3725,7 @@
           </a:p>
           <a:p xmlns:a="http://schemas.openxmlformats.org/drawingml/2006/main">
             <a:r>
-              <a:t>Usa cuatro ejemplos: reformular un texto, consultar una política interna, resolver una pregunta compuesta del curso e investigar una incompatibilidad reciente. RAG recupera documentos. CRAG evalúa si esa evidencia cubre la pregunta y puede corregir la búsqueda. Una investigación descompone la tarea, consulta fuentes y revisa las lagunas antes de redactar. Estas categorías se pueden combinar: una investigación también puede usar RAG. La multimodalidad describe las entradas o salidas, por lo que cualquiera de esos recorridos puede recibir una imagen. No presentes Deep Research como una garantía de exactitud ni como un nombre único de arquitectura.</a:t>
+              <a:t>Usa cuatro ejemplos de la tienda: reformular una respuesta, consultar el plazo de devolución, resolver una pregunta compuesta sobre envíos e investigar qué dice la normativa sobre un producto precintado. RAG recupera documentos. CRAG evalúa si esa evidencia cubre la pregunta y puede corregir la búsqueda. Una investigación descompone la tarea, consulta fuentes y revisa las lagunas antes de redactar. Estas categorías se pueden combinar: una investigación también puede usar RAG. La multimodalidad describe las entradas o salidas, por lo que cualquiera de esos recorridos puede recibir una imagen. No presentes Deep Research como una garantía de exactitud ni como un nombre único de arquitectura.</a:t>
             </a:r>
           </a:p>
           <a:p xmlns:a="http://schemas.openxmlformats.org/drawingml/2006/main">
@@ -3755,7 +3755,7 @@
           </a:p>
           <a:p xmlns:a="http://schemas.openxmlformats.org/drawingml/2006/main">
             <a:r>
-              <a:t>Si una investigación consulta el corpus del curso, ¿deja de ser investigación?</a:t>
+              <a:t>Si una investigación consulta las políticas de la tienda, ¿deja de ser investigación?</a:t>
             </a:r>
           </a:p>
           <a:p xmlns:a="http://schemas.openxmlformats.org/drawingml/2006/main">
@@ -3905,7 +3905,7 @@
           </a:p>
           <a:p xmlns:a="http://schemas.openxmlformats.org/drawingml/2006/main">
             <a:r>
-              <a:t>Define modalidad como una forma de representar información. Un modelo puede admitir texto e imagen, mientras otro servicio se encarga de transcribir audio. Un sistema multimodal no necesita resolverlo todo con una única llamada. En nuestro recorrido, la visión convierte la captura en una observación y la transcripción convierte el audio en texto. Después fusionamos esas entradas. Conservar el origen permite comprobar un número mal leído o una palabra mal transcrita. Un MP3 al final es una salida de voz. No implica que el sistema mantenga una conversación de voz en tiempo real.</a:t>
+              <a:t>Define modalidad como una forma de representar información. Un modelo puede admitir texto e imagen, mientras otro servicio se encarga de transcribir audio. Un sistema multimodal no necesita resolverlo todo con una única llamada. En nuestro recorrido, la visión convierte la foto del pedido en una observación y la transcripción convierte el audio en texto. Después fusionamos esas entradas. Conservar el origen permite comprobar un número mal leído o una palabra mal transcrita. Un MP3 al final es una salida de voz. No implica que el sistema mantenga una conversación de voz en tiempo real.</a:t>
             </a:r>
           </a:p>
           <a:p xmlns:a="http://schemas.openxmlformats.org/drawingml/2006/main">
@@ -3965,7 +3965,7 @@
           </a:p>
           <a:p xmlns:a="http://schemas.openxmlformats.org/drawingml/2006/main">
             <a:r>
-              <a:t>La primera transformación será leer una captura.</a:t>
+              <a:t>La primera transformación será leer la foto del pedido.</a:t>
             </a:r>
           </a:p>
           <a:p xmlns:a="http://schemas.openxmlformats.org/drawingml/2006/main">
@@ -4085,7 +4085,7 @@
           </a:p>
           <a:p xmlns:a="http://schemas.openxmlformats.org/drawingml/2006/main">
             <a:r>
-              <a:t>Distingue OCR e interpretación visual. OCR extrae caracteres. Un modelo con visión también puede describir el contexto de una pantalla, pero puede equivocarse con cifras, unidades o etiquetas. Lee expected 1024, got 768 sin invertir los valores. La imagen permite formular una hipótesis de incompatibilidad de dimensiones. No demuestra qué modelo usa el alumno ni cuál debería conservar. Antes de recomendar reconstruir un índice necesitamos comprobar la configuración real. El ejemplo es una imagen sintética del aula, no una captura de una incidencia de un alumno.</a:t>
+              <a:t>Distingue OCR e interpretación visual. OCR extrae caracteres. Un modelo con visión también puede describir el contexto de una pantalla, pero puede equivocarse con cifras, fechas o importes. Lee el número TPS-20481 y la fecha 20/10/2026 sin cambiar ningún dígito. La foto permite saber de qué pedido hablamos. No demuestra que el pedido sea de la cuenta de quien escribe ni qué le pasa al producto. Antes de responder necesitamos los datos del pedido desde la tienda y la explicación del cliente. El ejemplo es una imagen sintética de un pedido ficticio.</a:t>
             </a:r>
           </a:p>
           <a:p xmlns:a="http://schemas.openxmlformats.org/drawingml/2006/main">
@@ -4100,7 +4100,7 @@
           </a:p>
           <a:p xmlns:a="http://schemas.openxmlformats.org/drawingml/2006/main">
             <a:r>
-              <a:t>Pide a alguien que lea la captura y a otra persona que explique qué todavía no sabemos.</a:t>
+              <a:t>Pide a alguien que lea la foto y a otra persona que explique qué todavía no sabemos.</a:t>
             </a:r>
           </a:p>
           <a:p xmlns:a="http://schemas.openxmlformats.org/drawingml/2006/main">
@@ -4115,7 +4115,7 @@
           </a:p>
           <a:p xmlns:a="http://schemas.openxmlformats.org/drawingml/2006/main">
             <a:r>
-              <a:t>¿Podemos concluir que hay que cambiar el modelo por uno de 1024 dimensiones?</a:t>
+              <a:t>¿Podemos concluir ya que el cliente puede devolver los auriculares?</a:t>
             </a:r>
           </a:p>
           <a:p xmlns:a="http://schemas.openxmlformats.org/drawingml/2006/main">
@@ -4130,7 +4130,7 @@
           </a:p>
           <a:p xmlns:a="http://schemas.openxmlformats.org/drawingml/2006/main">
             <a:r>
-              <a:t>Todavía falta saber qué índice y qué modelo se han configurado y qué datos se quieren conservar.</a:t>
+              <a:t>Todavía falta saber qué les pasa, qué dice la política de la tienda y si el pedido es de su cuenta.</a:t>
             </a:r>
           </a:p>
           <a:p xmlns:a="http://schemas.openxmlformats.org/drawingml/2006/main">
@@ -4445,7 +4445,7 @@
           </a:p>
           <a:p xmlns:a="http://schemas.openxmlformats.org/drawingml/2006/main">
             <a:r>
-              <a:t>Explica speech to text como transcripción de voz a texto. El agente usará esa transcripción, de modo que una palabra mal reconocida puede cambiar la intención. En el ensayo guardado aparece Rack donde el audio se refería a RAG. Conservamos esa observación, no reescribimos la evidencia para que parezca perfecta. Podemos pedir aclaración o utilizar el contexto con cuidado, dejando visible el texto original. La nota de voz del caso indica que el error apareció después de cambiar el modelo de embeddings. Ese dato no figura en la captura y será importante al construir la pregunta de investigación.</a:t>
+              <a:t>Explica speech to text como transcripción de voz a texto. El agente usará esa transcripción, de modo que una palabra mal reconocida puede cambiar la intención. Un número de pedido o una marca mal reconocidos cambian la pregunta. Conservamos la transcripción tal como llegó, no la reescribimos para que parezca perfecta. Podemos pedir aclaración o utilizar el contexto con cuidado, dejando visible el texto original. La nota de voz del caso dice que el cliente abrió los auriculares y que el derecho no suena. Ese dato no figura en la foto y será importante al construir la pregunta de investigación.</a:t>
             </a:r>
           </a:p>
           <a:p xmlns:a="http://schemas.openxmlformats.org/drawingml/2006/main">
@@ -4460,7 +4460,7 @@
           </a:p>
           <a:p xmlns:a="http://schemas.openxmlformats.org/drawingml/2006/main">
             <a:r>
-              <a:t>Reproduce apps/api/fixtures/media/embedding-request.wav si el sonido compartido funciona. Después resume su intención sin atribuir una transcripción literal nueva.</a:t>
+              <a:t>Reproduce apps/api/fixtures/media/nota-de-voz-devolucion.wav si el sonido compartido funciona. Después resume su intención sin atribuir una transcripción literal nueva.</a:t>
             </a:r>
           </a:p>
           <a:p xmlns:a="http://schemas.openxmlformats.org/drawingml/2006/main">
@@ -4475,7 +4475,7 @@
           </a:p>
           <a:p xmlns:a="http://schemas.openxmlformats.org/drawingml/2006/main">
             <a:r>
-              <a:t>Si la transcripción cambia 768 por 786, ¿deberíamos seguir como si nada?</a:t>
+              <a:t>Si la transcripción cambia TPS-20481 por TPS-20418, ¿deberíamos seguir como si nada?</a:t>
             </a:r>
           </a:p>
           <a:p xmlns:a="http://schemas.openxmlformats.org/drawingml/2006/main">
@@ -4625,7 +4625,7 @@
           </a:p>
           <a:p xmlns:a="http://schemas.openxmlformats.org/drawingml/2006/main">
             <a:r>
-              <a:t>Construye la pregunta en voz alta utilizando las dos modalidades. La captura aporta cifras y el audio aporta el cambio que las precede. La fusión tiene que mantener la petición completa, incluidos matices y negaciones. Si las modalidades discrepan, el agente no debe elegir silenciosamente una. Si el contenido excede la capacidad admitida, pedimos acortar en lugar de recortar el final, donde podría estar la instrucción principal. Separa texto escrito, observación visual y transcripción. Esa separación permite volver a cada fuente al diagnosticar un fallo.</a:t>
+              <a:t>Construye la pregunta en voz alta utilizando las dos modalidades. La foto aporta el pedido y el audio aporta lo que le pasa y lo que quiere el cliente. La fusión tiene que mantener la petición completa, incluidos matices y negaciones. Si las modalidades discrepan, el agente no debe elegir silenciosamente una. Si el contenido excede la capacidad admitida, pedimos acortar en lugar de recortar el final, donde podría estar la instrucción principal. Separa texto escrito, observación visual y transcripción. Esa separación permite volver a cada fuente al diagnosticar un fallo.</a:t>
             </a:r>
           </a:p>
           <a:p xmlns:a="http://schemas.openxmlformats.org/drawingml/2006/main">
@@ -4640,7 +4640,7 @@
           </a:p>
           <a:p xmlns:a="http://schemas.openxmlformats.org/drawingml/2006/main">
             <a:r>
-              <a:t>Propón como contraste una imagen que diga 1024/768 y un audio que diga 768/1024. Pide al grupo que decida la salida antes de mostrar la respuesta esperada.</a:t>
+              <a:t>Propón como contraste la foto del pedido TPS-20481 y un audio que hable del pedido TPS-19876. Pide al grupo que decida la salida antes de mostrar la respuesta esperada.</a:t>
             </a:r>
           </a:p>
           <a:p xmlns:a="http://schemas.openxmlformats.org/drawingml/2006/main">
@@ -4670,7 +4670,7 @@
           </a:p>
           <a:p xmlns:a="http://schemas.openxmlformats.org/drawingml/2006/main">
             <a:r>
-              <a:t>Una aclaración que señale la discrepancia, sin empezar una investigación sobre cifras elegidas al azar.</a:t>
+              <a:t>Una aclaración que señale la discrepancia, sin investigar un pedido elegido al azar.</a:t>
             </a:r>
           </a:p>
           <a:p xmlns:a="http://schemas.openxmlformats.org/drawingml/2006/main">
@@ -9585,7 +9585,7 @@
       </p:sp>
       <p:sp>
         <p:nvSpPr>
-          <p:cNvPr id="7" name="Leer una ficha estructurada con argumentos validados">
+          <p:cNvPr id="7" name="Leer un dato estructurado con argumentos validados">
             <a:extLst xmlns:a="http://schemas.openxmlformats.org/drawingml/2006/main">
               <a:ext uri="{FF2B5EF4-FFF2-40B4-BE49-F238E27FC236}">
                 <a16:creationId xmlns:a16="http://schemas.microsoft.com/office/drawing/2014/main" id="{C726C78C-23FB-48C0-8C83-B46078ED7137}"/>
@@ -9736,7 +9736,7 @@
                 <a:ea typeface="Arial"/>
                 <a:cs typeface="Arial"/>
               </a:rPr>
-              <a:t>Leer una ficha estructurada con argumentos validados</a:t>
+              <a:t>Leer un dato estructurado con argumentos validados</a:t>
             </a:r>
           </a:p>
         </p:txBody>
@@ -10217,7 +10217,7 @@
       </p:sp>
       <p:sp>
         <p:nvSpPr>
-          <p:cNvPr id="11" name="get_course_session consulta la ficha S12 del grupo M/J">
+          <p:cNvPr id="11" name="get_order lee el pedido TPS-20481 de la cuenta de la conversación">
             <a:extLst xmlns:a="http://schemas.openxmlformats.org/drawingml/2006/main">
               <a:ext uri="{FF2B5EF4-FFF2-40B4-BE49-F238E27FC236}">
                 <a16:creationId xmlns:a16="http://schemas.microsoft.com/office/drawing/2014/main" id="{4F665CDC-2E18-49F4-9D8E-83F13E7EE4E9}"/>
@@ -10368,7 +10368,7 @@
                 <a:ea typeface="Arial"/>
                 <a:cs typeface="Arial"/>
               </a:rPr>
-              <a:t>get_course_session consulta la ficha S12 del grupo M/J</a:t>
+              <a:t>get_order lee el pedido TPS-20481 de la cuenta de la conversación</a:t>
             </a:r>
           </a:p>
         </p:txBody>
@@ -11064,7 +11064,7 @@
       </p:sp>
       <p:sp>
         <p:nvSpPr>
-          <p:cNvPr id="3" name="La memoria permite entender «ese índice» en el siguiente turno">
+          <p:cNvPr id="3" name="La memoria permite entender «ese pedido» en el siguiente turno">
             <a:extLst xmlns:a="http://schemas.openxmlformats.org/drawingml/2006/main">
               <a:ext uri="{FF2B5EF4-FFF2-40B4-BE49-F238E27FC236}">
                 <a16:creationId xmlns:a16="http://schemas.microsoft.com/office/drawing/2014/main" id="{3DE59B68-8C51-469E-8A82-7FED424BE15A}"/>
@@ -11215,7 +11215,7 @@
                 <a:ea typeface="Arial"/>
                 <a:cs typeface="Arial"/>
               </a:rPr>
-              <a:t>La memoria permite entender «ese índice» en el siguiente turno</a:t>
+              <a:t>La memoria permite entender «ese pedido» en el siguiente turno</a:t>
             </a:r>
           </a:p>
         </p:txBody>
@@ -31773,7 +31773,7 @@
                           <a:ea typeface="Arial"/>
                           <a:cs typeface="Arial"/>
                         </a:rPr>
-                        <a:t>Grafo propio con LangGraph y fuentes externas</a:t>
+                        <a:t>Grafo propio con LangGraph: políticas, pedidos y web</a:t>
                       </a:r>
                     </a:p>
                   </a:txBody>
@@ -31903,7 +31903,7 @@
                           <a:ea typeface="Arial"/>
                           <a:cs typeface="Arial"/>
                         </a:rPr>
-                        <a:t>Ensayo con Tavily y páginas de documentación</a:t>
+                        <a:t>Tavily y páginas oficiales de consumo (UE y BOE)</a:t>
                       </a:r>
                     </a:p>
                   </a:txBody>
@@ -32743,7 +32743,7 @@
       </p:sp>
       <p:sp>
         <p:nvSpPr>
-          <p:cNvPr id="3" name="La misma captura y el mismo audio durante todo el recorrido">
+          <p:cNvPr id="3" name="La misma foto y la misma nota de voz durante todo el recorrido">
             <a:extLst xmlns:a="http://schemas.openxmlformats.org/drawingml/2006/main">
               <a:ext uri="{FF2B5EF4-FFF2-40B4-BE49-F238E27FC236}">
                 <a16:creationId xmlns:a16="http://schemas.microsoft.com/office/drawing/2014/main" id="{B62AFC1B-C1ED-4511-8B3D-BD81366FA2A0}"/>
@@ -32894,7 +32894,7 @@
                 <a:ea typeface="Arial"/>
                 <a:cs typeface="Arial"/>
               </a:rPr>
-              <a:t>La misma captura y el mismo audio durante todo el recorrido</a:t>
+              <a:t>La misma foto y la misma nota de voz durante todo el recorrido</a:t>
             </a:r>
           </a:p>
         </p:txBody>
@@ -33059,7 +33059,7 @@
       </p:sp>
       <p:sp>
         <p:nvSpPr>
-          <p:cNvPr id="5" name="Adjuntar la captura y la nota de voz">
+          <p:cNvPr id="5" name="Adjuntar la foto del pedido y la nota de voz">
             <a:extLst xmlns:a="http://schemas.openxmlformats.org/drawingml/2006/main">
               <a:ext uri="{FF2B5EF4-FFF2-40B4-BE49-F238E27FC236}">
                 <a16:creationId xmlns:a16="http://schemas.microsoft.com/office/drawing/2014/main" id="{F1BCA1A1-7080-4C9C-8C6C-35B0CBEB3802}"/>
@@ -33210,7 +33210,7 @@
                 <a:ea typeface="Arial"/>
                 <a:cs typeface="Arial"/>
               </a:rPr>
-              <a:t>Adjuntar la captura y la nota de voz</a:t>
+              <a:t>Adjuntar la foto del pedido y la nota de voz</a:t>
             </a:r>
           </a:p>
         </p:txBody>
@@ -34007,7 +34007,7 @@
       </p:sp>
       <p:sp>
         <p:nvSpPr>
-          <p:cNvPr id="11" name="Recargar, preguntar «ese índice» y abrir otro hilo">
+          <p:cNvPr id="11" name="Recargar, preguntar «¿y ese pedido?» y abrir otro hilo">
             <a:extLst xmlns:a="http://schemas.openxmlformats.org/drawingml/2006/main">
               <a:ext uri="{FF2B5EF4-FFF2-40B4-BE49-F238E27FC236}">
                 <a16:creationId xmlns:a16="http://schemas.microsoft.com/office/drawing/2014/main" id="{F3D5E0E0-9784-4A42-A51D-E65C05D9868B}"/>
@@ -34158,7 +34158,7 @@
                 <a:ea typeface="Arial"/>
                 <a:cs typeface="Arial"/>
               </a:rPr>
-              <a:t>Recargar, preguntar «ese índice» y abrir otro hilo</a:t>
+              <a:t>Recargar, preguntar «¿y ese pedido?» y abrir otro hilo</a:t>
             </a:r>
           </a:p>
         </p:txBody>
@@ -44218,7 +44218,7 @@
       </p:sp>
       <p:sp>
         <p:nvSpPr>
-          <p:cNvPr id="3" name="La captura aporta una observación que todavía debemos interpretar">
+          <p:cNvPr id="3" name="La foto aporta una observación que todavía debemos interpretar">
             <a:extLst xmlns:a="http://schemas.openxmlformats.org/drawingml/2006/main">
               <a:ext uri="{FF2B5EF4-FFF2-40B4-BE49-F238E27FC236}">
                 <a16:creationId xmlns:a16="http://schemas.microsoft.com/office/drawing/2014/main" id="{D94D1D65-B7D1-4241-BDB5-C611D6ED533C}"/>
@@ -44369,7 +44369,7 @@
                 <a:ea typeface="Arial"/>
                 <a:cs typeface="Arial"/>
               </a:rPr>
-              <a:t>La captura aporta una observación que todavía debemos interpretar</a:t>
+              <a:t>La foto aporta una observación que todavía debemos interpretar</a:t>
             </a:r>
           </a:p>
         </p:txBody>
@@ -44562,7 +44562,7 @@
       </p:sp>
       <p:sp>
         <p:nvSpPr>
-          <p:cNvPr id="6" name="El sistema espera 1024 dimensiones y recibe 768">
+          <p:cNvPr id="6" name="Pedido TPS-20481: auriculares, Bizum, entregado el 20/10">
             <a:extLst xmlns:a="http://schemas.openxmlformats.org/drawingml/2006/main">
               <a:ext uri="{FF2B5EF4-FFF2-40B4-BE49-F238E27FC236}">
                 <a16:creationId xmlns:a16="http://schemas.microsoft.com/office/drawing/2014/main" id="{5992F548-D18B-45B6-89AF-571FCEAE6B8D}"/>
@@ -44713,7 +44713,7 @@
                 <a:ea typeface="Arial"/>
                 <a:cs typeface="Arial"/>
               </a:rPr>
-              <a:t>El sistema espera 1024 dimensiones y recibe 768</a:t>
+              <a:t>Pedido TPS-20481: auriculares, Bizum, entregado el 20/10</a:t>
             </a:r>
           </a:p>
         </p:txBody>
@@ -44878,7 +44878,7 @@
       </p:sp>
       <p:sp>
         <p:nvSpPr>
-          <p:cNvPr id="8" name="¿Qué configuración genera cada dimensión?">
+          <p:cNvPr id="8" name="¿Qué le pasa al pedido y qué quiere el cliente?">
             <a:extLst xmlns:a="http://schemas.openxmlformats.org/drawingml/2006/main">
               <a:ext uri="{FF2B5EF4-FFF2-40B4-BE49-F238E27FC236}">
                 <a16:creationId xmlns:a16="http://schemas.microsoft.com/office/drawing/2014/main" id="{CC73CA6F-3809-4D74-8BC4-8D48F0C50D3E}"/>
@@ -45029,7 +45029,7 @@
                 <a:ea typeface="Arial"/>
                 <a:cs typeface="Arial"/>
               </a:rPr>
-              <a:t>¿Qué configuración genera cada dimensión?</a:t>
+              <a:t>¿Qué le pasa al pedido y qué quiere el cliente?</a:t>
             </a:r>
           </a:p>
         </p:txBody>
@@ -45194,7 +45194,7 @@
       </p:sp>
       <p:sp>
         <p:nvSpPr>
-          <p:cNvPr id="10" name="Revisar el modelo y el índice antes de proponer cambios">
+          <p:cNvPr id="10" name="Confirmar el pedido con la herramienta antes de responder">
             <a:extLst xmlns:a="http://schemas.openxmlformats.org/drawingml/2006/main">
               <a:ext uri="{FF2B5EF4-FFF2-40B4-BE49-F238E27FC236}">
                 <a16:creationId xmlns:a16="http://schemas.microsoft.com/office/drawing/2014/main" id="{9E9C9BAA-849F-4E85-9035-8363D494AEC1}"/>
@@ -45345,14 +45345,14 @@
                 <a:ea typeface="Arial"/>
                 <a:cs typeface="Arial"/>
               </a:rPr>
-              <a:t>Revisar el modelo y el índice antes de proponer cambios</a:t>
+              <a:t>Confirmar el pedido con la herramienta antes de responder</a:t>
             </a:r>
           </a:p>
         </p:txBody>
       </p:sp>
       <p:sp>
         <p:nvSpPr>
-          <p:cNvPr id="11" name="Leer el error no identifica por sí solo la causa">
+          <p:cNvPr id="11" name="Leer la foto no explica por sí sola el problema">
             <a:extLst xmlns:a="http://schemas.openxmlformats.org/drawingml/2006/main">
               <a:ext uri="{FF2B5EF4-FFF2-40B4-BE49-F238E27FC236}">
                 <a16:creationId xmlns:a16="http://schemas.microsoft.com/office/drawing/2014/main" id="{D9A31418-3229-437E-B2E3-AC6D10E52A5D}"/>
@@ -45503,7 +45503,7 @@
                 <a:ea typeface="Arial"/>
                 <a:cs typeface="Arial"/>
               </a:rPr>
-              <a:t>Leer el error no identifica por sí solo la causa</a:t>
+              <a:t>Leer la foto no explica por sí sola el problema</a:t>
             </a:r>
           </a:p>
         </p:txBody>
@@ -49574,7 +49574,7 @@
       </p:sp>
       <p:sp>
         <p:nvSpPr>
-          <p:cNvPr id="12" name="El ensayo real transcribió «RAG» como «Rack»">
+          <p:cNvPr id="12" name="Un número o una marca mal transcritos cambian la pregunta">
             <a:extLst xmlns:a="http://schemas.openxmlformats.org/drawingml/2006/main">
               <a:ext uri="{FF2B5EF4-FFF2-40B4-BE49-F238E27FC236}">
                 <a16:creationId xmlns:a16="http://schemas.microsoft.com/office/drawing/2014/main" id="{E8B5EB77-0278-4C77-B38C-C02167E7739A}"/>
@@ -49725,7 +49725,7 @@
                 <a:ea typeface="Arial"/>
                 <a:cs typeface="Arial"/>
               </a:rPr>
-              <a:t>El ensayo real transcribió «RAG» como «Rack»</a:t>
+              <a:t>Un número o una marca mal transcritos cambian la pregunta</a:t>
             </a:r>
           </a:p>
         </p:txBody>
@@ -50579,7 +50579,7 @@
       </p:sp>
       <p:sp>
         <p:nvSpPr>
-          <p:cNvPr id="5" name="El índice espera 1024 y recibe 768">
+          <p:cNvPr id="5" name="Pedido TPS-20481: auriculares pagados con Bizum">
             <a:extLst xmlns:a="http://schemas.openxmlformats.org/drawingml/2006/main">
               <a:ext uri="{FF2B5EF4-FFF2-40B4-BE49-F238E27FC236}">
                 <a16:creationId xmlns:a16="http://schemas.microsoft.com/office/drawing/2014/main" id="{535A3642-E282-4C27-B8BC-E6CA91DCC661}"/>
@@ -50730,7 +50730,7 @@
                 <a:ea typeface="Arial"/>
                 <a:cs typeface="Arial"/>
               </a:rPr>
-              <a:t>El índice espera 1024 y recibe 768</a:t>
+              <a:t>Pedido TPS-20481: auriculares pagados con Bizum</a:t>
             </a:r>
           </a:p>
         </p:txBody>
@@ -50895,7 +50895,7 @@
       </p:sp>
       <p:sp>
         <p:nvSpPr>
-          <p:cNvPr id="7" name="El error apareció después de cambiar embeddings">
+          <p:cNvPr id="7" name="Los abrió y el auricular derecho no suena">
             <a:extLst xmlns:a="http://schemas.openxmlformats.org/drawingml/2006/main">
               <a:ext uri="{FF2B5EF4-FFF2-40B4-BE49-F238E27FC236}">
                 <a16:creationId xmlns:a16="http://schemas.microsoft.com/office/drawing/2014/main" id="{56BCAFB8-6224-4DAC-8E09-120A1906546C}"/>
@@ -51046,7 +51046,7 @@
                 <a:ea typeface="Arial"/>
                 <a:cs typeface="Arial"/>
               </a:rPr>
-              <a:t>El error apareció después de cambiar embeddings</a:t>
+              <a:t>Los abrió y el auricular derecho no suena</a:t>
             </a:r>
           </a:p>
         </p:txBody>
@@ -51211,7 +51211,7 @@
       </p:sp>
       <p:sp>
         <p:nvSpPr>
-          <p:cNvPr id="9" name="Investigar el significado y qué configuración revisar">
+          <p:cNvPr id="9" name="Saber si puede devolverlos y cuándo recibe el dinero">
             <a:extLst xmlns:a="http://schemas.openxmlformats.org/drawingml/2006/main">
               <a:ext uri="{FF2B5EF4-FFF2-40B4-BE49-F238E27FC236}">
                 <a16:creationId xmlns:a16="http://schemas.microsoft.com/office/drawing/2014/main" id="{7B21CE16-F738-4D24-BE39-13E6084F6294}"/>
@@ -51362,7 +51362,7 @@
                 <a:ea typeface="Arial"/>
                 <a:cs typeface="Arial"/>
               </a:rPr>
-              <a:t>Investigar el significado y qué configuración revisar</a:t>
+              <a:t>Saber si puede devolverlos y cuándo recibe el dinero</a:t>
             </a:r>
           </a:p>
         </p:txBody>
@@ -51527,7 +51527,7 @@
       </p:sp>
       <p:sp>
         <p:nvSpPr>
-          <p:cNvPr id="11" name="Qué relación deben tener modelo e índice y cómo comprobarla">
+          <p:cNvPr id="11" name="Qué dicen la política de la tienda y la normativa para este pedido">
             <a:extLst xmlns:a="http://schemas.openxmlformats.org/drawingml/2006/main">
               <a:ext uri="{FF2B5EF4-FFF2-40B4-BE49-F238E27FC236}">
                 <a16:creationId xmlns:a16="http://schemas.microsoft.com/office/drawing/2014/main" id="{B1CB6375-2366-4BF7-9B5A-CD36201608E9}"/>
@@ -51678,7 +51678,7 @@
                 <a:ea typeface="Arial"/>
                 <a:cs typeface="Arial"/>
               </a:rPr>
-              <a:t>Qué relación deben tener modelo e índice y cómo comprobarla</a:t>
+              <a:t>Qué dicen la política de la tienda y la normativa para este pedido</a:t>
             </a:r>
           </a:p>
         </p:txBody>

</xml_diff>

<commit_message>
docs(s12): drop the old rehearsal evidence and rebuild the S12 material
Slide 23 now explains what to check in a real run, with a capture of the
local demo report instead of the 11 October rehearsal of the previous case.
The script PDF is regenerated with its own generator, the deck PDF is
re-exported, both generators carry the new text, and the teacher ZIP is
rebuilt with the packaging rules, which leave out private build files.
README, AGENTS.md and decisions describe the demo following CHAT_CORPUS.
</commit_message>
<xml_diff>
--- a/material/S12/S12-deep-research-multimodal.pptx
+++ b/material/S12/S12-deep-research-multimodal.pptx
@@ -570,7 +570,7 @@
           </a:p>
           <a:p xmlns:a="http://schemas.openxmlformats.org/drawingml/2006/main">
             <a:r>
-              <a:t>Documentación externa consultada: 18/10/2026. Los ensayos de producción citados son del 11/10/2026.</a:t>
+              <a:t>Documentación externa consultada: 18/10/2026. La demo de la tienda es local y usa guiones.</a:t>
             </a:r>
           </a:p>
         </p:txBody>
@@ -750,7 +750,7 @@
           </a:p>
           <a:p xmlns:a="http://schemas.openxmlformats.org/drawingml/2006/main">
             <a:r>
-              <a:t>Documentación externa consultada: 18/10/2026. Los ensayos de producción citados son del 11/10/2026.</a:t>
+              <a:t>Documentación externa consultada: 18/10/2026. La demo de la tienda es local y usa guiones.</a:t>
             </a:r>
           </a:p>
         </p:txBody>
@@ -930,7 +930,7 @@
           </a:p>
           <a:p xmlns:a="http://schemas.openxmlformats.org/drawingml/2006/main">
             <a:r>
-              <a:t>Documentación externa consultada: 18/10/2026. Los ensayos de producción citados son del 11/10/2026.</a:t>
+              <a:t>Documentación externa consultada: 18/10/2026. La demo de la tienda es local y usa guiones.</a:t>
             </a:r>
           </a:p>
         </p:txBody>
@@ -1115,7 +1115,7 @@
           </a:p>
           <a:p xmlns:a="http://schemas.openxmlformats.org/drawingml/2006/main">
             <a:r>
-              <a:t>Documentación externa consultada: 18/10/2026. Los ensayos de producción citados son del 11/10/2026.</a:t>
+              <a:t>Documentación externa consultada: 18/10/2026. La demo de la tienda es local y usa guiones.</a:t>
             </a:r>
           </a:p>
         </p:txBody>
@@ -1295,7 +1295,7 @@
           </a:p>
           <a:p xmlns:a="http://schemas.openxmlformats.org/drawingml/2006/main">
             <a:r>
-              <a:t>Documentación externa consultada: 18/10/2026. Los ensayos de producción citados son del 11/10/2026.</a:t>
+              <a:t>Documentación externa consultada: 18/10/2026. La demo de la tienda es local y usa guiones.</a:t>
             </a:r>
           </a:p>
         </p:txBody>
@@ -1470,12 +1470,12 @@
           </a:p>
           <a:p xmlns:a="http://schemas.openxmlformats.org/drawingml/2006/main">
             <a:r>
-              <a:t>docs/s12-cloud-deployment.md#ensayo-real-de-extremo-a-extremo</a:t>
-            </a:r>
-          </a:p>
-          <a:p xmlns:a="http://schemas.openxmlformats.org/drawingml/2006/main">
-            <a:r>
-              <a:t>Documentación externa consultada: 18/10/2026. Los ensayos de producción citados son del 11/10/2026.</a:t>
+              <a:t>docs/despliegue-real.md</a:t>
+            </a:r>
+          </a:p>
+          <a:p xmlns:a="http://schemas.openxmlformats.org/drawingml/2006/main">
+            <a:r>
+              <a:t>Documentación externa consultada: 18/10/2026. La demo de la tienda es local y usa guiones.</a:t>
             </a:r>
           </a:p>
         </p:txBody>
@@ -1655,7 +1655,7 @@
           </a:p>
           <a:p xmlns:a="http://schemas.openxmlformats.org/drawingml/2006/main">
             <a:r>
-              <a:t>Documentación externa consultada: 18/10/2026. Los ensayos de producción citados son del 11/10/2026.</a:t>
+              <a:t>Documentación externa consultada: 18/10/2026. La demo de la tienda es local y usa guiones.</a:t>
             </a:r>
           </a:p>
         </p:txBody>
@@ -1840,7 +1840,7 @@
           </a:p>
           <a:p xmlns:a="http://schemas.openxmlformats.org/drawingml/2006/main">
             <a:r>
-              <a:t>Documentación externa consultada: 18/10/2026. Los ensayos de producción citados son del 11/10/2026.</a:t>
+              <a:t>Documentación externa consultada: 18/10/2026. La demo de la tienda es local y usa guiones.</a:t>
             </a:r>
           </a:p>
         </p:txBody>
@@ -1930,7 +1930,7 @@
           </a:p>
           <a:p xmlns:a="http://schemas.openxmlformats.org/drawingml/2006/main">
             <a:r>
-              <a:t>Explica por qué una investigación autónoma necesita condiciones de parada. Los valores de la diapositiva proceden del contrato actual de la app, no son un estándar de Deep Research ni el límite universal de Gemini. Visión, transcripción y voz tienen su propia contabilidad y comparten el plazo global. Reservar un máximo antes de enviar permite rechazar una nueva llamada cuando no hay presupuesto. Tokens medidos, un precio estimado y un importe facturado son datos diferentes. Una petición enviada cuyo resultado se desconoce no debe repetirse a ciegas. En el aula principal usaremos el modo local sin gasto y evidencia real anterior.</a:t>
+              <a:t>Explica por qué una investigación autónoma necesita condiciones de parada. Los valores de la diapositiva proceden del contrato actual de la app, no son un estándar de Deep Research ni el límite universal de Gemini. Visión, transcripción y voz tienen su propia contabilidad y comparten el plazo global. Reservar un máximo antes de enviar permite rechazar una nueva llamada cuando no hay presupuesto. Tokens medidos, un precio estimado y un importe facturado son datos diferentes. Una petición enviada cuyo resultado se desconoce no debe repetirse a ciegas. En el aula usaremos el modo local sin gasto.</a:t>
             </a:r>
           </a:p>
           <a:p xmlns:a="http://schemas.openxmlformats.org/drawingml/2006/main">
@@ -2025,7 +2025,7 @@
           </a:p>
           <a:p xmlns:a="http://schemas.openxmlformats.org/drawingml/2006/main">
             <a:r>
-              <a:t>Documentación externa consultada: 18/10/2026. Los ensayos de producción citados son del 11/10/2026.</a:t>
+              <a:t>Documentación externa consultada: 18/10/2026. La demo de la tienda es local y usa guiones.</a:t>
             </a:r>
           </a:p>
         </p:txBody>
@@ -2115,7 +2115,7 @@
           </a:p>
           <a:p xmlns:a="http://schemas.openxmlformats.org/drawingml/2006/main">
             <a:r>
-              <a:t>Define text to speech como síntesis de voz a partir de texto. En la app no pedimos al TTS que invente un resumen. Primero seleccionamos frases que han pasado la verificación y después generamos el audio. Esto facilita comparar lo escrito con lo hablado. Si el informe es parcial, la locución puede indicarlo. La generación y la reproducción son pasos distintos: un MP3 correcto no prueba que el alumno haya compartido el sonido de su ordenador. En el modo offline, la salida de prueba es un tono rotulado y no voz neural. El MP3 guardado del ensayo real sí permite escuchar una síntesis anterior.</a:t>
+              <a:t>Define text to speech como síntesis de voz a partir de texto. En la app no pedimos al TTS que invente un resumen. Primero seleccionamos frases que han pasado la verificación y después generamos el audio. Esto facilita comparar lo escrito con lo hablado. Si el informe es parcial, la locución puede indicarlo. La generación y la reproducción son pasos distintos: un MP3 correcto no prueba que el alumno haya compartido el sonido de su ordenador. En el modo offline, la salida de prueba es un tono rotulado y no voz neural. En una ejecución real, el MP3 sí es voz neural generada con Aura.</a:t>
             </a:r>
           </a:p>
           <a:p xmlns:a="http://schemas.openxmlformats.org/drawingml/2006/main">
@@ -2130,7 +2130,7 @@
           </a:p>
           <a:p xmlns:a="http://schemas.openxmlformats.org/drawingml/2006/main">
             <a:r>
-              <a:t>Recuerda ensayar la opción de compartir audio en la reunión. Si no funciona, muestra el texto de la locución y el archivo guardado.</a:t>
+              <a:t>Recuerda ensayar la opción de compartir audio en la reunión. Si no funciona, muestra el texto de la locución y el reproductor en pantalla.</a:t>
             </a:r>
           </a:p>
           <a:p xmlns:a="http://schemas.openxmlformats.org/drawingml/2006/main">
@@ -2205,7 +2205,7 @@
           </a:p>
           <a:p xmlns:a="http://schemas.openxmlformats.org/drawingml/2006/main">
             <a:r>
-              <a:t>Documentación externa consultada: 18/10/2026. Los ensayos de producción citados son del 11/10/2026.</a:t>
+              <a:t>Documentación externa consultada: 18/10/2026. La demo de la tienda es local y usa guiones.</a:t>
             </a:r>
           </a:p>
         </p:txBody>
@@ -2385,7 +2385,7 @@
           </a:p>
           <a:p xmlns:a="http://schemas.openxmlformats.org/drawingml/2006/main">
             <a:r>
-              <a:t>Documentación externa consultada: 18/10/2026. Los ensayos de producción citados son del 11/10/2026.</a:t>
+              <a:t>Documentación externa consultada: 18/10/2026. La demo de la tienda es local y usa guiones.</a:t>
             </a:r>
           </a:p>
         </p:txBody>
@@ -2560,7 +2560,7 @@
           </a:p>
           <a:p xmlns:a="http://schemas.openxmlformats.org/drawingml/2006/main">
             <a:r>
-              <a:t>Documentación externa consultada: 18/10/2026. Los ensayos de producción citados son del 11/10/2026.</a:t>
+              <a:t>Documentación externa consultada: 18/10/2026. La demo de la tienda es local y usa guiones.</a:t>
             </a:r>
           </a:p>
         </p:txBody>
@@ -2740,7 +2740,7 @@
           </a:p>
           <a:p xmlns:a="http://schemas.openxmlformats.org/drawingml/2006/main">
             <a:r>
-              <a:t>Documentación externa consultada: 18/10/2026. Los ensayos de producción citados son del 11/10/2026.</a:t>
+              <a:t>Documentación externa consultada: 18/10/2026. La demo de la tienda es local y usa guiones.</a:t>
             </a:r>
           </a:p>
         </p:txBody>
@@ -2830,7 +2830,7 @@
           </a:p>
           <a:p xmlns:a="http://schemas.openxmlformats.org/drawingml/2006/main">
             <a:r>
-              <a:t>Presenta las decisiones de la app después de haber explicado las responsabilidades. LangGraph controla la investigación y consulta las políticas de la tienda, la herramienta de pedidos y la web. El ensayo real se hizo con Claude para texto e imagen, Whisper para audio y Aura para voz. La fábrica actual permite configurar el proveedor generativo, pero no prometemos compatibilidad universal con cualquier modelo de visión. La persistencia utiliza servicios de Cloudflare. Estos nombres describen nuestra implementación y no requisitos conceptuales de multimodalidad. La ruta Gemini/Interactions del enunciado no queda implementada por el hecho de que esta app tenga un grafo equivalente.</a:t>
+              <a:t>Presenta las decisiones de la app después de haber explicado las responsabilidades. LangGraph controla la investigación y consulta las políticas de la tienda, la herramienta de pedidos y la web. La configuración publicada usa Claude Haiku para texto e imagen, Whisper para audio y Aura para voz. La fábrica actual permite configurar el proveedor generativo, pero no prometemos compatibilidad universal con cualquier modelo de visión. La persistencia utiliza servicios de Cloudflare. Estos nombres describen nuestra implementación y no requisitos conceptuales de multimodalidad. La ruta Gemini/Interactions del enunciado no queda implementada por el hecho de que esta app tenga un grafo equivalente.</a:t>
             </a:r>
           </a:p>
           <a:p xmlns:a="http://schemas.openxmlformats.org/drawingml/2006/main">
@@ -2915,12 +2915,12 @@
           </a:p>
           <a:p xmlns:a="http://schemas.openxmlformats.org/drawingml/2006/main">
             <a:r>
-              <a:t>docs/s12-cloud-deployment.md#ensayo-real-de-extremo-a-extremo</a:t>
-            </a:r>
-          </a:p>
-          <a:p xmlns:a="http://schemas.openxmlformats.org/drawingml/2006/main">
-            <a:r>
-              <a:t>Documentación externa consultada: 18/10/2026. Los ensayos de producción citados son del 11/10/2026.</a:t>
+              <a:t>docs/despliegue-real.md</a:t>
+            </a:r>
+          </a:p>
+          <a:p xmlns:a="http://schemas.openxmlformats.org/drawingml/2006/main">
+            <a:r>
+              <a:t>Documentación externa consultada: 18/10/2026. La demo de la tienda es local y usa guiones.</a:t>
             </a:r>
           </a:p>
         </p:txBody>
@@ -3010,7 +3010,7 @@
           </a:p>
           <a:p xmlns:a="http://schemas.openxmlformats.org/drawingml/2006/main">
             <a:r>
-              <a:t>Usa el perfil local de investigación con sus guiones rotulados. Adjunta pedido-auriculares.png y nota-de-voz-devolucion.wav, marca Generar voz y envía sin escribir la pregunta. Muestra que la observación y la intención se conservan por separado, que aparecen plan y fuentes y que el resultado se guarda. El tono offline es una prueba técnica, no una voz neural. Recarga y comprueba el mismo informe. Haz un seguimiento breve con «¿y ese pedido?» y después abre otra conversación para mostrar aislamiento. El guion detallado y los tiempos de corte están en el apartado de demostración del documento del profesor. La consulta a get_order y las fuentes del caso real se pueden recorrer en el respaldo guardado.</a:t>
+              <a:t>Usa el perfil local de investigación con sus guiones rotulados. Adjunta pedido-auriculares.png y nota-de-voz-devolucion.wav, marca Generar voz y envía sin escribir la pregunta. Muestra que la observación y la intención se conservan por separado, que aparecen plan y fuentes y que el resultado se guarda. El tono offline es una prueba técnica, no una voz neural. Recarga y comprueba el mismo informe. Haz un seguimiento breve con «¿y ese pedido?» y después abre otra conversación para mostrar aislamiento. El guion detallado y los tiempos de corte están en el apartado de demostración del documento del profesor. Si la app falla, la captura de respaldo enseña el mismo informe con la consulta a get_order y sus fuentes.</a:t>
             </a:r>
           </a:p>
           <a:p xmlns:a="http://schemas.openxmlformats.org/drawingml/2006/main">
@@ -3100,7 +3100,7 @@
           </a:p>
           <a:p xmlns:a="http://schemas.openxmlformats.org/drawingml/2006/main">
             <a:r>
-              <a:t>Documentación externa consultada: 18/10/2026. Los ensayos de producción citados son del 11/10/2026.</a:t>
+              <a:t>Documentación externa consultada: 18/10/2026. La demo de la tienda es local y usa guiones.</a:t>
             </a:r>
           </a:p>
         </p:txBody>
@@ -3170,7 +3170,7 @@
           <a:lstStyle xmlns:a="http://schemas.openxmlformats.org/drawingml/2006/main"/>
           <a:p xmlns:a="http://schemas.openxmlformats.org/drawingml/2006/main">
             <a:r>
-              <a:t>23 · Lo observado en el ensayo real</a:t>
+              <a:t>23 · Qué comprobar en una ejecución real</a:t>
             </a:r>
           </a:p>
           <a:p xmlns:a="http://schemas.openxmlformats.org/drawingml/2006/main">
@@ -3190,7 +3190,7 @@
           </a:p>
           <a:p xmlns:a="http://schemas.openxmlformats.org/drawingml/2006/main">
             <a:r>
-              <a:t>Explica que estas cifras proceden del ensayo del 11 de octubre, no de la sesión que acabamos de ejecutar. Los dos trabajos recorrieron imagen, audio, herramienta del curso, búsqueda, lectura y voz. El segundo completó sus 18 operaciones y mantuvo un informe parcial porque faltaba evidencia sobre la configuración concreta. Reproduce el MP3 guardado y señala el texto de la voz. La recarga recuperó informe y audio, y se comprobó que no creó operaciones pagadas adicionales. No presentes las reservas de presupuesto como una factura ni uses dos ejemplos para afirmar una precisión general. El documento de despliegue contiene la identidad y los límites de esa evidencia histórica.</a:t>
+              <a:t>Explica que la demostración de hoy usa guiones locales y no proveedores reales: sirve para ver el recorrido, no para medir un modelo. En una ejecución real con la foto y la nota de voz hay tres comprobaciones. La identidad: un único ID de trabajo que, al recargar, devuelve el mismo informe y la misma voz sin crear operaciones de pago nuevas. Las tres vías: un fragmento de las políticas, el resultado de get_order y al menos una página oficial leída, cada una sosteniendo solo su parte del informe. El dinero: la reserva previa no supera el tope de 0,25 USD por trabajo y una llamada sin resultado conocido queda como desconocida, nunca como cero. No presentes una reserva como factura ni un ejemplo como una precisión general.</a:t>
             </a:r>
           </a:p>
           <a:p xmlns:a="http://schemas.openxmlformats.org/drawingml/2006/main">
@@ -3205,7 +3205,7 @@
           </a:p>
           <a:p xmlns:a="http://schemas.openxmlformats.org/drawingml/2006/main">
             <a:r>
-              <a:t>Abre respaldo/informe-parcial-ensayo-20261011.png y reproduce respaldo/voz-ensayo-20261011.mp3. Si no puedes compartir sonido, lee el texto de la captura.</a:t>
+              <a:t>Señala en la captura de la demo local (respaldo/informe-demo-local.png) una fuente de cada tipo (política, pedido y web) y el reproductor de voz. Si quieres enseñar una ejecución real, lánzala antes de clase desde tu navegador en la web publicada, con la foto y la nota de voz, y deja visibles su fecha y su ID.</a:t>
             </a:r>
           </a:p>
           <a:p xmlns:a="http://schemas.openxmlformats.org/drawingml/2006/main">
@@ -3220,7 +3220,7 @@
           </a:p>
           <a:p xmlns:a="http://schemas.openxmlformats.org/drawingml/2006/main">
             <a:r>
-              <a:t>¿Cómo puede haber 8 afirmaciones verificadas y seguir faltando una respuesta completa?</a:t>
+              <a:t>¿Cómo sabemos que recargar no ha lanzado otra investigación?</a:t>
             </a:r>
           </a:p>
           <a:p xmlns:a="http://schemas.openxmlformats.org/drawingml/2006/main">
@@ -3235,7 +3235,7 @@
           </a:p>
           <a:p xmlns:a="http://schemas.openxmlformats.org/drawingml/2006/main">
             <a:r>
-              <a:t>Las frases comprobadas no necesariamente cubren todas las subpreguntas del usuario.</a:t>
+              <a:t>Porque vuelve el mismo ID de trabajo y su registro no tiene operaciones de pago nuevas.</a:t>
             </a:r>
           </a:p>
           <a:p xmlns:a="http://schemas.openxmlformats.org/drawingml/2006/main">
@@ -3265,22 +3265,22 @@
           </a:p>
           <a:p xmlns:a="http://schemas.openxmlformats.org/drawingml/2006/main">
             <a:r>
-              <a:t>docs/s12-cloud-deployment.md#ensayo-real-de-extremo-a-extremo</a:t>
-            </a:r>
-          </a:p>
-          <a:p xmlns:a="http://schemas.openxmlformats.org/drawingml/2006/main">
-            <a:r>
-              <a:t>material/S12/respaldo/informe-parcial-ensayo-20261011.png</a:t>
-            </a:r>
-          </a:p>
-          <a:p xmlns:a="http://schemas.openxmlformats.org/drawingml/2006/main">
-            <a:r>
-              <a:t>material/S12/respaldo/voz-ensayo-20261011.mp3</a:t>
-            </a:r>
-          </a:p>
-          <a:p xmlns:a="http://schemas.openxmlformats.org/drawingml/2006/main">
-            <a:r>
-              <a:t>Documentación externa consultada: 18/10/2026. Los ensayos de producción citados son del 11/10/2026.</a:t>
+              <a:t>docs/despliegue-real.md</a:t>
+            </a:r>
+          </a:p>
+          <a:p xmlns:a="http://schemas.openxmlformats.org/drawingml/2006/main">
+            <a:r>
+              <a:t>material/S12/respaldo/informe-demo-local.png</a:t>
+            </a:r>
+          </a:p>
+          <a:p xmlns:a="http://schemas.openxmlformats.org/drawingml/2006/main">
+            <a:r>
+              <a:t>apps/api/src/research-money.ts</a:t>
+            </a:r>
+          </a:p>
+          <a:p xmlns:a="http://schemas.openxmlformats.org/drawingml/2006/main">
+            <a:r>
+              <a:t>Documentación externa consultada: 18/10/2026. La demo de la tienda es local y usa guiones.</a:t>
             </a:r>
           </a:p>
         </p:txBody>
@@ -3460,7 +3460,7 @@
           </a:p>
           <a:p xmlns:a="http://schemas.openxmlformats.org/drawingml/2006/main">
             <a:r>
-              <a:t>Documentación externa consultada: 18/10/2026. Los ensayos de producción citados son del 11/10/2026.</a:t>
+              <a:t>Documentación externa consultada: 18/10/2026. La demo de la tienda es local y usa guiones.</a:t>
             </a:r>
           </a:p>
         </p:txBody>
@@ -3550,7 +3550,7 @@
           </a:p>
           <a:p xmlns:a="http://schemas.openxmlformats.org/drawingml/2006/main">
             <a:r>
-              <a:t>Lee el objetivo como un comportamiento observable. El alumno no tiene que construir una interfaz web ni varios agentes. Puede entregar un terminal o notebook que recorra las capacidades. Durante la primera hora separaremos cada responsabilidad para que después resulte sencillo encontrar un fallo. La última media hora se dedica a la aplicación existente, un resultado real guardado y las condiciones del ejercicio. Distingue siempre el diseño del agente, el proveedor de modelos y la infraestructura que lo ejecuta.</a:t>
+              <a:t>Lee el objetivo como un comportamiento observable. El alumno no tiene que construir una interfaz web ni varios agentes. Puede entregar un terminal o notebook que recorra las capacidades. Durante la primera hora separaremos cada responsabilidad para que después resulte sencillo encontrar un fallo. La última media hora se dedica a la aplicación existente, a cómo se comprueba una ejecución real y a las condiciones del ejercicio. Distingue siempre el diseño del agente, el proveedor de modelos y la infraestructura que lo ejecuta.</a:t>
             </a:r>
           </a:p>
           <a:p xmlns:a="http://schemas.openxmlformats.org/drawingml/2006/main">
@@ -3635,7 +3635,7 @@
           </a:p>
           <a:p xmlns:a="http://schemas.openxmlformats.org/drawingml/2006/main">
             <a:r>
-              <a:t>Documentación externa consultada: 18/10/2026. Los ensayos de producción citados son del 11/10/2026.</a:t>
+              <a:t>Documentación externa consultada: 18/10/2026. La demo de la tienda es local y usa guiones.</a:t>
             </a:r>
           </a:p>
         </p:txBody>
@@ -3815,7 +3815,7 @@
           </a:p>
           <a:p xmlns:a="http://schemas.openxmlformats.org/drawingml/2006/main">
             <a:r>
-              <a:t>Documentación externa consultada: 18/10/2026. Los ensayos de producción citados son del 11/10/2026.</a:t>
+              <a:t>Documentación externa consultada: 18/10/2026. La demo de la tienda es local y usa guiones.</a:t>
             </a:r>
           </a:p>
         </p:txBody>
@@ -3995,7 +3995,7 @@
           </a:p>
           <a:p xmlns:a="http://schemas.openxmlformats.org/drawingml/2006/main">
             <a:r>
-              <a:t>Documentación externa consultada: 18/10/2026. Los ensayos de producción citados son del 11/10/2026.</a:t>
+              <a:t>Documentación externa consultada: 18/10/2026. La demo de la tienda es local y usa guiones.</a:t>
             </a:r>
           </a:p>
         </p:txBody>
@@ -4175,7 +4175,7 @@
           </a:p>
           <a:p xmlns:a="http://schemas.openxmlformats.org/drawingml/2006/main">
             <a:r>
-              <a:t>Documentación externa consultada: 18/10/2026. Los ensayos de producción citados son del 11/10/2026.</a:t>
+              <a:t>Documentación externa consultada: 18/10/2026. La demo de la tienda es local y usa guiones.</a:t>
             </a:r>
           </a:p>
         </p:txBody>
@@ -4355,7 +4355,7 @@
           </a:p>
           <a:p xmlns:a="http://schemas.openxmlformats.org/drawingml/2006/main">
             <a:r>
-              <a:t>Documentación externa consultada: 18/10/2026. Los ensayos de producción citados son del 11/10/2026.</a:t>
+              <a:t>Documentación externa consultada: 18/10/2026. La demo de la tienda es local y usa guiones.</a:t>
             </a:r>
           </a:p>
         </p:txBody>
@@ -4535,7 +4535,7 @@
           </a:p>
           <a:p xmlns:a="http://schemas.openxmlformats.org/drawingml/2006/main">
             <a:r>
-              <a:t>Documentación externa consultada: 18/10/2026. Los ensayos de producción citados son del 11/10/2026.</a:t>
+              <a:t>Documentación externa consultada: 18/10/2026. La demo de la tienda es local y usa guiones.</a:t>
             </a:r>
           </a:p>
         </p:txBody>
@@ -4715,7 +4715,7 @@
           </a:p>
           <a:p xmlns:a="http://schemas.openxmlformats.org/drawingml/2006/main">
             <a:r>
-              <a:t>Documentación externa consultada: 18/10/2026. Los ensayos de producción citados son del 11/10/2026.</a:t>
+              <a:t>Documentación externa consultada: 18/10/2026. La demo de la tienda es local y usa guiones.</a:t>
             </a:r>
           </a:p>
         </p:txBody>
@@ -31838,7 +31838,7 @@
                           <a:ea typeface="Arial"/>
                           <a:cs typeface="Arial"/>
                         </a:rPr>
-                        <a:t>Proveedor configurado · ensayo con Claude Haiku 5.5</a:t>
+                        <a:t>Proveedor configurado · Claude Haiku 5.5 publicado</a:t>
                       </a:r>
                     </a:p>
                   </a:txBody>
@@ -34165,7 +34165,7 @@
       </p:sp>
       <p:sp>
         <p:nvSpPr>
-          <p:cNvPr id="12" name="Demo principal local sin gasto · ensayo real guardado a continuación">
+          <p:cNvPr id="12" name="Demo principal local sin gasto · a continuación, qué comprobar en una ejecución real">
             <a:extLst xmlns:a="http://schemas.openxmlformats.org/drawingml/2006/main">
               <a:ext uri="{FF2B5EF4-FFF2-40B4-BE49-F238E27FC236}">
                 <a16:creationId xmlns:a16="http://schemas.microsoft.com/office/drawing/2014/main" id="{EFC1A739-DCF5-4E38-8F2B-DDD4FB45C7BB}"/>
@@ -34316,7 +34316,7 @@
                 <a:ea typeface="Arial"/>
                 <a:cs typeface="Arial"/>
               </a:rPr>
-              <a:t>Demo principal local sin gasto · ensayo real guardado a continuación</a:t>
+              <a:t>Demo principal local sin gasto · a continuación, qué comprobar en una ejecución real</a:t>
             </a:r>
           </a:p>
         </p:txBody>
@@ -34696,7 +34696,7 @@
       </p:pic>
       <p:sp>
         <p:nvSpPr>
-          <p:cNvPr id="2" name="Lo observado en el ensayo real">
+          <p:cNvPr id="2" name="Qué comprobar en una ejecución real">
             <a:extLst xmlns:a="http://schemas.openxmlformats.org/drawingml/2006/main">
               <a:ext uri="{FF2B5EF4-FFF2-40B4-BE49-F238E27FC236}">
                 <a16:creationId xmlns:a16="http://schemas.microsoft.com/office/drawing/2014/main" id="{164F0D5E-E97A-45ED-822A-A0B6726B97FF}"/>
@@ -34847,14 +34847,14 @@
                 <a:ea typeface="Arial"/>
                 <a:cs typeface="Arial"/>
               </a:rPr>
-              <a:t>Lo observado en el ensayo real</a:t>
+              <a:t>Qué comprobar en una ejecución real</a:t>
             </a:r>
           </a:p>
         </p:txBody>
       </p:sp>
       <p:sp>
         <p:nvSpPr>
-          <p:cNvPr id="3" name="Ejecuciones guardadas del 11 de octubre de 2026">
+          <p:cNvPr id="3" name="La demo local enseña el recorrido; un trabajo real se comprueba así">
             <a:extLst xmlns:a="http://schemas.openxmlformats.org/drawingml/2006/main">
               <a:ext uri="{FF2B5EF4-FFF2-40B4-BE49-F238E27FC236}">
                 <a16:creationId xmlns:a16="http://schemas.microsoft.com/office/drawing/2014/main" id="{D0AE5CA3-A3D8-4250-9CD1-ACED9D4AFA23}"/>
@@ -35005,14 +35005,14 @@
                 <a:ea typeface="Arial"/>
                 <a:cs typeface="Arial"/>
               </a:rPr>
-              <a:t>Ejecuciones guardadas del 11 de octubre de 2026</a:t>
+              <a:t>La demo local enseña el recorrido; un trabajo real se comprueba así</a:t>
             </a:r>
           </a:p>
         </p:txBody>
       </p:sp>
       <p:sp>
         <p:nvSpPr>
-          <p:cNvPr id="4" name="48,712 s">
+          <p:cNvPr id="4" name="1 ID">
             <a:extLst xmlns:a="http://schemas.openxmlformats.org/drawingml/2006/main">
               <a:ext uri="{FF2B5EF4-FFF2-40B4-BE49-F238E27FC236}">
                 <a16:creationId xmlns:a16="http://schemas.microsoft.com/office/drawing/2014/main" id="{686EBAE7-8D45-46D4-9649-ED247DD9F54F}"/>
@@ -35163,14 +35163,14 @@
                 <a:ea typeface="Arial"/>
                 <a:cs typeface="Arial"/>
               </a:rPr>
-              <a:t>48,712 s</a:t>
+              <a:t>1 ID</a:t>
             </a:r>
           </a:p>
         </p:txBody>
       </p:sp>
       <p:sp>
         <p:nvSpPr>
-          <p:cNvPr id="5" name="Informe completo con 7 afirmaciones verificadas">
+          <p:cNvPr id="5" name="El mismo trabajo al recargar, sin operaciones de pago nuevas">
             <a:extLst xmlns:a="http://schemas.openxmlformats.org/drawingml/2006/main">
               <a:ext uri="{FF2B5EF4-FFF2-40B4-BE49-F238E27FC236}">
                 <a16:creationId xmlns:a16="http://schemas.microsoft.com/office/drawing/2014/main" id="{AC1FD487-AA8A-4784-BEB0-C1001AFEB15D}"/>
@@ -35321,14 +35321,14 @@
                 <a:ea typeface="Arial"/>
                 <a:cs typeface="Arial"/>
               </a:rPr>
-              <a:t>Informe completo con 7 afirmaciones verificadas</a:t>
+              <a:t>El mismo trabajo al recargar, sin operaciones de pago nuevas</a:t>
             </a:r>
           </a:p>
         </p:txBody>
       </p:sp>
       <p:sp>
         <p:nvSpPr>
-          <p:cNvPr id="6" name="45,158 s">
+          <p:cNvPr id="6" name="3 vías">
             <a:extLst xmlns:a="http://schemas.openxmlformats.org/drawingml/2006/main">
               <a:ext uri="{FF2B5EF4-FFF2-40B4-BE49-F238E27FC236}">
                 <a16:creationId xmlns:a16="http://schemas.microsoft.com/office/drawing/2014/main" id="{AF8B5991-C8C3-49B9-A663-757BFB7AEB62}"/>
@@ -35479,14 +35479,14 @@
                 <a:ea typeface="Arial"/>
                 <a:cs typeface="Arial"/>
               </a:rPr>
-              <a:t>45,158 s</a:t>
+              <a:t>3 vías</a:t>
             </a:r>
           </a:p>
         </p:txBody>
       </p:sp>
       <p:sp>
         <p:nvSpPr>
-          <p:cNvPr id="7" name="Informe parcial con 8 afirmaciones verificadas">
+          <p:cNvPr id="7" name="Políticas, get_order y normativa, cada una con su fuente">
             <a:extLst xmlns:a="http://schemas.openxmlformats.org/drawingml/2006/main">
               <a:ext uri="{FF2B5EF4-FFF2-40B4-BE49-F238E27FC236}">
                 <a16:creationId xmlns:a16="http://schemas.microsoft.com/office/drawing/2014/main" id="{04723CA8-6AF9-4A81-AD68-A494ACA7237A}"/>
@@ -35637,14 +35637,14 @@
                 <a:ea typeface="Arial"/>
                 <a:cs typeface="Arial"/>
               </a:rPr>
-              <a:t>Informe parcial con 8 afirmaciones verificadas</a:t>
+              <a:t>Políticas, get_order y normativa, cada una con su fuente</a:t>
             </a:r>
           </a:p>
         </p:txBody>
       </p:sp>
       <p:sp>
         <p:nvSpPr>
-          <p:cNvPr id="8" name="24,504 s">
+          <p:cNvPr id="8" name="0,25 USD">
             <a:extLst xmlns:a="http://schemas.openxmlformats.org/drawingml/2006/main">
               <a:ext uri="{FF2B5EF4-FFF2-40B4-BE49-F238E27FC236}">
                 <a16:creationId xmlns:a16="http://schemas.microsoft.com/office/drawing/2014/main" id="{6B04006B-A601-47A4-94FF-30A901011F4A}"/>
@@ -35795,14 +35795,14 @@
                 <a:ea typeface="Arial"/>
                 <a:cs typeface="Arial"/>
               </a:rPr>
-              <a:t>24,504 s</a:t>
+              <a:t>0,25 USD</a:t>
             </a:r>
           </a:p>
         </p:txBody>
       </p:sp>
       <p:sp>
         <p:nvSpPr>
-          <p:cNvPr id="9" name="Audio real recuperado y reproducido tras la recarga">
+          <p:cNvPr id="9" name="Tope por trabajo; lo desconocido queda retenido">
             <a:extLst xmlns:a="http://schemas.openxmlformats.org/drawingml/2006/main">
               <a:ext uri="{FF2B5EF4-FFF2-40B4-BE49-F238E27FC236}">
                 <a16:creationId xmlns:a16="http://schemas.microsoft.com/office/drawing/2014/main" id="{81C0959C-EAC5-4FC8-AFFB-887ACB876B0E}"/>
@@ -35953,7 +35953,7 @@
                 <a:ea typeface="Arial"/>
                 <a:cs typeface="Arial"/>
               </a:rPr>
-              <a:t>Audio real recuperado y reproducido tras la recarga</a:t>
+              <a:t>Tope por trabajo; lo desconocido queda retenido</a:t>
             </a:r>
           </a:p>
         </p:txBody>
@@ -35988,7 +35988,7 @@
       </p:pic>
       <p:sp>
         <p:nvSpPr>
-          <p:cNvPr id="11" name="Son ejemplos del recorrido y no una tasa general de precisión">
+          <p:cNvPr id="11" name="Son comprobaciones del recorrido, no una tasa general de precisión">
             <a:extLst xmlns:a="http://schemas.openxmlformats.org/drawingml/2006/main">
               <a:ext uri="{FF2B5EF4-FFF2-40B4-BE49-F238E27FC236}">
                 <a16:creationId xmlns:a16="http://schemas.microsoft.com/office/drawing/2014/main" id="{FBA68345-E013-4CC9-97A6-43879988F168}"/>
@@ -36139,7 +36139,7 @@
                 <a:ea typeface="Arial"/>
                 <a:cs typeface="Arial"/>
               </a:rPr>
-              <a:t>Son ejemplos del recorrido y no una tasa general de precisión</a:t>
+              <a:t>Son comprobaciones del recorrido, no una tasa general de precisión</a:t>
             </a:r>
           </a:p>
         </p:txBody>

</xml_diff>